<commit_message>
add benchmarking to presentation
</commit_message>
<xml_diff>
--- a/Presentation/BrainTumorSegmentation_final_presentation.pptx
+++ b/Presentation/BrainTumorSegmentation_final_presentation.pptx
@@ -5,7 +5,7 @@
     <p:sldMasterId id="2147483673" r:id="rId1"/>
   </p:sldMasterIdLst>
   <p:notesMasterIdLst>
-    <p:notesMasterId r:id="rId21"/>
+    <p:notesMasterId r:id="rId22"/>
   </p:notesMasterIdLst>
   <p:sldIdLst>
     <p:sldId id="256" r:id="rId2"/>
@@ -19,14 +19,15 @@
     <p:sldId id="265" r:id="rId10"/>
     <p:sldId id="259" r:id="rId11"/>
     <p:sldId id="271" r:id="rId12"/>
-    <p:sldId id="272" r:id="rId13"/>
-    <p:sldId id="258" r:id="rId14"/>
-    <p:sldId id="270" r:id="rId15"/>
-    <p:sldId id="274" r:id="rId16"/>
-    <p:sldId id="275" r:id="rId17"/>
-    <p:sldId id="276" r:id="rId18"/>
-    <p:sldId id="277" r:id="rId19"/>
-    <p:sldId id="278" r:id="rId20"/>
+    <p:sldId id="279" r:id="rId13"/>
+    <p:sldId id="272" r:id="rId14"/>
+    <p:sldId id="258" r:id="rId15"/>
+    <p:sldId id="270" r:id="rId16"/>
+    <p:sldId id="274" r:id="rId17"/>
+    <p:sldId id="275" r:id="rId18"/>
+    <p:sldId id="276" r:id="rId19"/>
+    <p:sldId id="277" r:id="rId20"/>
+    <p:sldId id="278" r:id="rId21"/>
   </p:sldIdLst>
   <p:sldSz cx="12192000" cy="6858000"/>
   <p:notesSz cx="6858000" cy="9144000"/>
@@ -584,7 +585,7 @@
           <a:p>
             <a:fld id="{C441223F-4C2C-5B48-8083-441942F24941}" type="slidenum">
               <a:rPr lang="de-DE" smtClean="0"/>
-              <a:t>13</a:t>
+              <a:t>14</a:t>
             </a:fld>
             <a:endParaRPr lang="de-DE"/>
           </a:p>
@@ -6302,6 +6303,218 @@
           <p:cNvPr id="2" name="Titel 1">
             <a:extLst>
               <a:ext uri="{FF2B5EF4-FFF2-40B4-BE49-F238E27FC236}">
+                <a16:creationId xmlns:a16="http://schemas.microsoft.com/office/drawing/2014/main" id="{53542375-6C89-DEAE-84D8-F841B1D3D5B9}"/>
+              </a:ext>
+            </a:extLst>
+          </p:cNvPr>
+          <p:cNvSpPr>
+            <a:spLocks noGrp="1"/>
+          </p:cNvSpPr>
+          <p:nvPr>
+            <p:ph type="title"/>
+          </p:nvPr>
+        </p:nvSpPr>
+        <p:spPr/>
+        <p:txBody>
+          <a:bodyPr/>
+          <a:lstStyle/>
+          <a:p>
+            <a:r>
+              <a:rPr lang="de-DE" dirty="0"/>
+              <a:t>Model Training</a:t>
+            </a:r>
+          </a:p>
+        </p:txBody>
+      </p:sp>
+      <p:sp>
+        <p:nvSpPr>
+          <p:cNvPr id="3" name="Inhaltsplatzhalter 2">
+            <a:extLst>
+              <a:ext uri="{FF2B5EF4-FFF2-40B4-BE49-F238E27FC236}">
+                <a16:creationId xmlns:a16="http://schemas.microsoft.com/office/drawing/2014/main" id="{3DB01028-9DD0-FA54-DDB8-0FE62D22AF95}"/>
+              </a:ext>
+            </a:extLst>
+          </p:cNvPr>
+          <p:cNvSpPr>
+            <a:spLocks noGrp="1"/>
+          </p:cNvSpPr>
+          <p:nvPr>
+            <p:ph idx="1"/>
+          </p:nvPr>
+        </p:nvSpPr>
+        <p:spPr/>
+        <p:txBody>
+          <a:bodyPr/>
+          <a:lstStyle/>
+          <a:p>
+            <a:r>
+              <a:rPr lang="de-DE" dirty="0"/>
+              <a:t>Benchmarking </a:t>
+            </a:r>
+            <a:r>
+              <a:rPr lang="de-DE" dirty="0" err="1"/>
+              <a:t>done</a:t>
+            </a:r>
+            <a:r>
+              <a:rPr lang="de-DE" dirty="0"/>
+              <a:t> </a:t>
+            </a:r>
+            <a:r>
+              <a:rPr lang="de-DE" dirty="0" err="1"/>
+              <a:t>for</a:t>
+            </a:r>
+            <a:r>
+              <a:rPr lang="de-DE" dirty="0"/>
+              <a:t> 5 </a:t>
+            </a:r>
+            <a:r>
+              <a:rPr lang="de-DE" dirty="0" err="1"/>
+              <a:t>epochs</a:t>
+            </a:r>
+            <a:r>
+              <a:rPr lang="de-DE" dirty="0"/>
+              <a:t> </a:t>
+            </a:r>
+            <a:r>
+              <a:rPr lang="de-DE" dirty="0" err="1"/>
+              <a:t>for</a:t>
+            </a:r>
+            <a:r>
+              <a:rPr lang="de-DE" dirty="0"/>
+              <a:t> </a:t>
+            </a:r>
+          </a:p>
+          <a:p>
+            <a:pPr lvl="1"/>
+            <a:r>
+              <a:rPr lang="de-DE" dirty="0"/>
+              <a:t>2D </a:t>
+            </a:r>
+            <a:r>
+              <a:rPr lang="de-DE" dirty="0" err="1"/>
+              <a:t>model</a:t>
+            </a:r>
+            <a:endParaRPr lang="de-DE" dirty="0"/>
+          </a:p>
+          <a:p>
+            <a:pPr lvl="1"/>
+            <a:r>
+              <a:rPr lang="de-DE" dirty="0"/>
+              <a:t>3D </a:t>
+            </a:r>
+            <a:r>
+              <a:rPr lang="de-DE" dirty="0" err="1"/>
+              <a:t>model</a:t>
+            </a:r>
+            <a:endParaRPr lang="de-DE" dirty="0"/>
+          </a:p>
+          <a:p>
+            <a:r>
+              <a:rPr lang="de-DE" dirty="0" err="1"/>
+              <a:t>Results</a:t>
+            </a:r>
+            <a:r>
+              <a:rPr lang="de-DE" dirty="0"/>
+              <a:t>: </a:t>
+            </a:r>
+            <a:r>
+              <a:rPr lang="de-DE" dirty="0" err="1">
+                <a:highlight>
+                  <a:srgbClr val="FFFF00"/>
+                </a:highlight>
+              </a:rPr>
+              <a:t>has</a:t>
+            </a:r>
+            <a:r>
+              <a:rPr lang="de-DE" dirty="0">
+                <a:highlight>
+                  <a:srgbClr val="FFFF00"/>
+                </a:highlight>
+              </a:rPr>
+              <a:t> </a:t>
+            </a:r>
+            <a:r>
+              <a:rPr lang="de-DE" dirty="0" err="1">
+                <a:highlight>
+                  <a:srgbClr val="FFFF00"/>
+                </a:highlight>
+              </a:rPr>
+              <a:t>to</a:t>
+            </a:r>
+            <a:r>
+              <a:rPr lang="de-DE" dirty="0">
+                <a:highlight>
+                  <a:srgbClr val="FFFF00"/>
+                </a:highlight>
+              </a:rPr>
+              <a:t> </a:t>
+            </a:r>
+            <a:r>
+              <a:rPr lang="de-DE" dirty="0" err="1">
+                <a:highlight>
+                  <a:srgbClr val="FFFF00"/>
+                </a:highlight>
+              </a:rPr>
+              <a:t>be</a:t>
+            </a:r>
+            <a:r>
+              <a:rPr lang="de-DE" dirty="0">
+                <a:highlight>
+                  <a:srgbClr val="FFFF00"/>
+                </a:highlight>
+              </a:rPr>
+              <a:t> </a:t>
+            </a:r>
+            <a:r>
+              <a:rPr lang="de-DE" dirty="0" err="1">
+                <a:highlight>
+                  <a:srgbClr val="FFFF00"/>
+                </a:highlight>
+              </a:rPr>
+              <a:t>added</a:t>
+            </a:r>
+            <a:br>
+              <a:rPr lang="de-DE" dirty="0"/>
+            </a:br>
+            <a:endParaRPr lang="de-DE" dirty="0"/>
+          </a:p>
+        </p:txBody>
+      </p:sp>
+    </p:spTree>
+    <p:extLst>
+      <p:ext uri="{BB962C8B-B14F-4D97-AF65-F5344CB8AC3E}">
+        <p14:creationId xmlns:p14="http://schemas.microsoft.com/office/powerpoint/2010/main" val="194275383"/>
+      </p:ext>
+    </p:extLst>
+  </p:cSld>
+  <p:clrMapOvr>
+    <a:masterClrMapping/>
+  </p:clrMapOvr>
+</p:sld>
+</file>
+
+<file path=ppt/slides/slide13.xml><?xml version="1.0" encoding="utf-8"?>
+<p:sld xmlns:a="http://schemas.openxmlformats.org/drawingml/2006/main" xmlns:r="http://schemas.openxmlformats.org/officeDocument/2006/relationships" xmlns:p="http://schemas.openxmlformats.org/presentationml/2006/main">
+  <p:cSld>
+    <p:spTree>
+      <p:nvGrpSpPr>
+        <p:cNvPr id="1" name=""/>
+        <p:cNvGrpSpPr/>
+        <p:nvPr/>
+      </p:nvGrpSpPr>
+      <p:grpSpPr>
+        <a:xfrm>
+          <a:off x="0" y="0"/>
+          <a:ext cx="0" cy="0"/>
+          <a:chOff x="0" y="0"/>
+          <a:chExt cx="0" cy="0"/>
+        </a:xfrm>
+      </p:grpSpPr>
+      <p:sp>
+        <p:nvSpPr>
+          <p:cNvPr id="2" name="Titel 1">
+            <a:extLst>
+              <a:ext uri="{FF2B5EF4-FFF2-40B4-BE49-F238E27FC236}">
                 <a16:creationId xmlns:a16="http://schemas.microsoft.com/office/drawing/2014/main" id="{1CA22F96-E19A-8C18-AE01-81C70171DBA2}"/>
               </a:ext>
             </a:extLst>
@@ -6465,7 +6678,7 @@
 </p:sld>
 </file>
 
-<file path=ppt/slides/slide13.xml><?xml version="1.0" encoding="utf-8"?>
+<file path=ppt/slides/slide14.xml><?xml version="1.0" encoding="utf-8"?>
 <p:sld xmlns:a="http://schemas.openxmlformats.org/drawingml/2006/main" xmlns:r="http://schemas.openxmlformats.org/officeDocument/2006/relationships" xmlns:p="http://schemas.openxmlformats.org/presentationml/2006/main">
   <p:cSld>
     <p:bg>
@@ -6938,7 +7151,7 @@
 </p:sld>
 </file>
 
-<file path=ppt/slides/slide14.xml><?xml version="1.0" encoding="utf-8"?>
+<file path=ppt/slides/slide15.xml><?xml version="1.0" encoding="utf-8"?>
 <p:sld xmlns:a="http://schemas.openxmlformats.org/drawingml/2006/main" xmlns:r="http://schemas.openxmlformats.org/officeDocument/2006/relationships" xmlns:p="http://schemas.openxmlformats.org/presentationml/2006/main">
   <p:cSld>
     <p:spTree>
@@ -7117,7 +7330,7 @@
 </p:sld>
 </file>
 
-<file path=ppt/slides/slide15.xml><?xml version="1.0" encoding="utf-8"?>
+<file path=ppt/slides/slide16.xml><?xml version="1.0" encoding="utf-8"?>
 <p:sld xmlns:a="http://schemas.openxmlformats.org/drawingml/2006/main" xmlns:r="http://schemas.openxmlformats.org/officeDocument/2006/relationships" xmlns:p="http://schemas.openxmlformats.org/presentationml/2006/main">
   <p:cSld>
     <p:spTree>
@@ -7291,7 +7504,7 @@
 </p:sld>
 </file>
 
-<file path=ppt/slides/slide16.xml><?xml version="1.0" encoding="utf-8"?>
+<file path=ppt/slides/slide17.xml><?xml version="1.0" encoding="utf-8"?>
 <p:sld xmlns:a="http://schemas.openxmlformats.org/drawingml/2006/main" xmlns:r="http://schemas.openxmlformats.org/officeDocument/2006/relationships" xmlns:p="http://schemas.openxmlformats.org/presentationml/2006/main">
   <p:cSld>
     <p:spTree>
@@ -7447,7 +7660,7 @@
 </p:sld>
 </file>
 
-<file path=ppt/slides/slide17.xml><?xml version="1.0" encoding="utf-8"?>
+<file path=ppt/slides/slide18.xml><?xml version="1.0" encoding="utf-8"?>
 <p:sld xmlns:a="http://schemas.openxmlformats.org/drawingml/2006/main" xmlns:r="http://schemas.openxmlformats.org/officeDocument/2006/relationships" xmlns:p="http://schemas.openxmlformats.org/presentationml/2006/main">
   <p:cSld>
     <p:spTree>
@@ -7603,7 +7816,7 @@
 </p:sld>
 </file>
 
-<file path=ppt/slides/slide18.xml><?xml version="1.0" encoding="utf-8"?>
+<file path=ppt/slides/slide19.xml><?xml version="1.0" encoding="utf-8"?>
 <p:sld xmlns:a="http://schemas.openxmlformats.org/drawingml/2006/main" xmlns:r="http://schemas.openxmlformats.org/officeDocument/2006/relationships" xmlns:p="http://schemas.openxmlformats.org/presentationml/2006/main">
   <p:cSld>
     <p:spTree>
@@ -7741,675 +7954,6 @@
     <p:extLst>
       <p:ext uri="{BB962C8B-B14F-4D97-AF65-F5344CB8AC3E}">
         <p14:creationId xmlns:p14="http://schemas.microsoft.com/office/powerpoint/2010/main" val="998473610"/>
-      </p:ext>
-    </p:extLst>
-  </p:cSld>
-  <p:clrMapOvr>
-    <a:masterClrMapping/>
-  </p:clrMapOvr>
-</p:sld>
-</file>
-
-<file path=ppt/slides/slide19.xml><?xml version="1.0" encoding="utf-8"?>
-<p:sld xmlns:a="http://schemas.openxmlformats.org/drawingml/2006/main" xmlns:r="http://schemas.openxmlformats.org/officeDocument/2006/relationships" xmlns:p="http://schemas.openxmlformats.org/presentationml/2006/main">
-  <p:cSld>
-    <p:spTree>
-      <p:nvGrpSpPr>
-        <p:cNvPr id="1" name=""/>
-        <p:cNvGrpSpPr/>
-        <p:nvPr/>
-      </p:nvGrpSpPr>
-      <p:grpSpPr>
-        <a:xfrm>
-          <a:off x="0" y="0"/>
-          <a:ext cx="0" cy="0"/>
-          <a:chOff x="0" y="0"/>
-          <a:chExt cx="0" cy="0"/>
-        </a:xfrm>
-      </p:grpSpPr>
-      <p:sp>
-        <p:nvSpPr>
-          <p:cNvPr id="2" name="Titel 1">
-            <a:extLst>
-              <a:ext uri="{FF2B5EF4-FFF2-40B4-BE49-F238E27FC236}">
-                <a16:creationId xmlns:a16="http://schemas.microsoft.com/office/drawing/2014/main" id="{38CB1CBC-D7B9-75B5-CE88-82E3A32A7561}"/>
-              </a:ext>
-            </a:extLst>
-          </p:cNvPr>
-          <p:cNvSpPr>
-            <a:spLocks noGrp="1"/>
-          </p:cNvSpPr>
-          <p:nvPr>
-            <p:ph type="title"/>
-          </p:nvPr>
-        </p:nvSpPr>
-        <p:spPr/>
-        <p:txBody>
-          <a:bodyPr/>
-          <a:lstStyle/>
-          <a:p>
-            <a:r>
-              <a:rPr lang="de-DE" dirty="0" err="1"/>
-              <a:t>Conclusion</a:t>
-            </a:r>
-            <a:r>
-              <a:rPr lang="de-DE" dirty="0"/>
-              <a:t> </a:t>
-            </a:r>
-          </a:p>
-        </p:txBody>
-      </p:sp>
-      <p:sp>
-        <p:nvSpPr>
-          <p:cNvPr id="3" name="Inhaltsplatzhalter 2">
-            <a:extLst>
-              <a:ext uri="{FF2B5EF4-FFF2-40B4-BE49-F238E27FC236}">
-                <a16:creationId xmlns:a16="http://schemas.microsoft.com/office/drawing/2014/main" id="{C9B5F5CC-EC14-D5C3-36CC-F4B2BB3DF4C7}"/>
-              </a:ext>
-            </a:extLst>
-          </p:cNvPr>
-          <p:cNvSpPr>
-            <a:spLocks noGrp="1"/>
-          </p:cNvSpPr>
-          <p:nvPr>
-            <p:ph idx="1"/>
-          </p:nvPr>
-        </p:nvSpPr>
-        <p:spPr/>
-        <p:txBody>
-          <a:bodyPr/>
-          <a:lstStyle/>
-          <a:p>
-            <a:pPr>
-              <a:lnSpc>
-                <a:spcPct val="110000"/>
-              </a:lnSpc>
-            </a:pPr>
-            <a:r>
-              <a:rPr lang="de-AT" b="0" i="0" u="none" strike="noStrike" dirty="0">
-                <a:solidFill>
-                  <a:srgbClr val="D1D5DB"/>
-                </a:solidFill>
-                <a:effectLst/>
-                <a:latin typeface="Söhne"/>
-              </a:rPr>
-              <a:t>The </a:t>
-            </a:r>
-            <a:r>
-              <a:rPr lang="de-AT" b="0" i="0" u="none" strike="noStrike" dirty="0" err="1">
-                <a:solidFill>
-                  <a:srgbClr val="D1D5DB"/>
-                </a:solidFill>
-                <a:effectLst/>
-                <a:latin typeface="Söhne"/>
-              </a:rPr>
-              <a:t>model</a:t>
-            </a:r>
-            <a:r>
-              <a:rPr lang="de-AT" b="0" i="0" u="none" strike="noStrike" dirty="0">
-                <a:solidFill>
-                  <a:srgbClr val="D1D5DB"/>
-                </a:solidFill>
-                <a:effectLst/>
-                <a:latin typeface="Söhne"/>
-              </a:rPr>
-              <a:t> </a:t>
-            </a:r>
-            <a:r>
-              <a:rPr lang="de-AT" b="0" i="0" u="none" strike="noStrike" dirty="0" err="1">
-                <a:solidFill>
-                  <a:srgbClr val="D1D5DB"/>
-                </a:solidFill>
-                <a:effectLst/>
-                <a:latin typeface="Söhne"/>
-              </a:rPr>
-              <a:t>effectively</a:t>
-            </a:r>
-            <a:r>
-              <a:rPr lang="de-AT" b="0" i="0" u="none" strike="noStrike" dirty="0">
-                <a:solidFill>
-                  <a:srgbClr val="D1D5DB"/>
-                </a:solidFill>
-                <a:effectLst/>
-                <a:latin typeface="Söhne"/>
-              </a:rPr>
-              <a:t> </a:t>
-            </a:r>
-            <a:r>
-              <a:rPr lang="de-AT" b="0" i="0" u="none" strike="noStrike" dirty="0" err="1">
-                <a:solidFill>
-                  <a:srgbClr val="D1D5DB"/>
-                </a:solidFill>
-                <a:effectLst/>
-                <a:latin typeface="Söhne"/>
-              </a:rPr>
-              <a:t>identifies</a:t>
-            </a:r>
-            <a:r>
-              <a:rPr lang="de-AT" b="0" i="0" u="none" strike="noStrike" dirty="0">
-                <a:solidFill>
-                  <a:srgbClr val="D1D5DB"/>
-                </a:solidFill>
-                <a:effectLst/>
-                <a:latin typeface="Söhne"/>
-              </a:rPr>
-              <a:t> </a:t>
-            </a:r>
-            <a:r>
-              <a:rPr lang="de-AT" b="0" i="0" u="none" strike="noStrike" dirty="0" err="1">
-                <a:solidFill>
-                  <a:srgbClr val="D1D5DB"/>
-                </a:solidFill>
-                <a:effectLst/>
-                <a:latin typeface="Söhne"/>
-              </a:rPr>
-              <a:t>clear</a:t>
-            </a:r>
-            <a:r>
-              <a:rPr lang="de-AT" b="0" i="0" u="none" strike="noStrike" dirty="0">
-                <a:solidFill>
-                  <a:srgbClr val="D1D5DB"/>
-                </a:solidFill>
-                <a:effectLst/>
-                <a:latin typeface="Söhne"/>
-              </a:rPr>
-              <a:t> </a:t>
-            </a:r>
-            <a:r>
-              <a:rPr lang="de-AT" b="0" i="0" u="none" strike="noStrike" dirty="0" err="1">
-                <a:solidFill>
-                  <a:srgbClr val="D1D5DB"/>
-                </a:solidFill>
-                <a:effectLst/>
-                <a:latin typeface="Söhne"/>
-              </a:rPr>
-              <a:t>tumors</a:t>
-            </a:r>
-            <a:r>
-              <a:rPr lang="de-AT" b="0" i="0" u="none" strike="noStrike" dirty="0">
-                <a:solidFill>
-                  <a:srgbClr val="D1D5DB"/>
-                </a:solidFill>
-                <a:effectLst/>
-                <a:latin typeface="Söhne"/>
-              </a:rPr>
-              <a:t> but </a:t>
-            </a:r>
-            <a:r>
-              <a:rPr lang="de-AT" b="0" i="0" u="none" strike="noStrike" dirty="0" err="1">
-                <a:solidFill>
-                  <a:srgbClr val="D1D5DB"/>
-                </a:solidFill>
-                <a:effectLst/>
-                <a:latin typeface="Söhne"/>
-              </a:rPr>
-              <a:t>struggles</a:t>
-            </a:r>
-            <a:r>
-              <a:rPr lang="de-AT" b="0" i="0" u="none" strike="noStrike" dirty="0">
-                <a:solidFill>
-                  <a:srgbClr val="D1D5DB"/>
-                </a:solidFill>
-                <a:effectLst/>
-                <a:latin typeface="Söhne"/>
-              </a:rPr>
-              <a:t> </a:t>
-            </a:r>
-            <a:r>
-              <a:rPr lang="de-AT" b="0" i="0" u="none" strike="noStrike" dirty="0" err="1">
-                <a:solidFill>
-                  <a:srgbClr val="D1D5DB"/>
-                </a:solidFill>
-                <a:effectLst/>
-                <a:latin typeface="Söhne"/>
-              </a:rPr>
-              <a:t>with</a:t>
-            </a:r>
-            <a:r>
-              <a:rPr lang="de-AT" b="0" i="0" u="none" strike="noStrike" dirty="0">
-                <a:solidFill>
-                  <a:srgbClr val="D1D5DB"/>
-                </a:solidFill>
-                <a:effectLst/>
-                <a:latin typeface="Söhne"/>
-              </a:rPr>
-              <a:t> </a:t>
-            </a:r>
-            <a:r>
-              <a:rPr lang="de-AT" b="0" i="0" u="none" strike="noStrike" dirty="0" err="1">
-                <a:solidFill>
-                  <a:srgbClr val="D1D5DB"/>
-                </a:solidFill>
-                <a:effectLst/>
-                <a:latin typeface="Söhne"/>
-              </a:rPr>
-              <a:t>less</a:t>
-            </a:r>
-            <a:r>
-              <a:rPr lang="de-AT" b="0" i="0" u="none" strike="noStrike" dirty="0">
-                <a:solidFill>
-                  <a:srgbClr val="D1D5DB"/>
-                </a:solidFill>
-                <a:effectLst/>
-                <a:latin typeface="Söhne"/>
-              </a:rPr>
-              <a:t> </a:t>
-            </a:r>
-            <a:r>
-              <a:rPr lang="de-AT" b="0" i="0" u="none" strike="noStrike" dirty="0" err="1">
-                <a:solidFill>
-                  <a:srgbClr val="D1D5DB"/>
-                </a:solidFill>
-                <a:effectLst/>
-                <a:latin typeface="Söhne"/>
-              </a:rPr>
-              <a:t>distinct</a:t>
-            </a:r>
-            <a:r>
-              <a:rPr lang="de-AT" b="0" i="0" u="none" strike="noStrike" dirty="0">
-                <a:solidFill>
-                  <a:srgbClr val="D1D5DB"/>
-                </a:solidFill>
-                <a:effectLst/>
-                <a:latin typeface="Söhne"/>
-              </a:rPr>
-              <a:t> </a:t>
-            </a:r>
-            <a:r>
-              <a:rPr lang="de-AT" b="0" i="0" u="none" strike="noStrike" dirty="0" err="1">
-                <a:solidFill>
-                  <a:srgbClr val="D1D5DB"/>
-                </a:solidFill>
-                <a:effectLst/>
-                <a:latin typeface="Söhne"/>
-              </a:rPr>
-              <a:t>ones</a:t>
-            </a:r>
-            <a:r>
-              <a:rPr lang="de-AT" b="0" i="0" u="none" strike="noStrike" dirty="0">
-                <a:solidFill>
-                  <a:srgbClr val="D1D5DB"/>
-                </a:solidFill>
-                <a:effectLst/>
-                <a:latin typeface="Söhne"/>
-              </a:rPr>
-              <a:t>. </a:t>
-            </a:r>
-          </a:p>
-          <a:p>
-            <a:pPr>
-              <a:lnSpc>
-                <a:spcPct val="110000"/>
-              </a:lnSpc>
-            </a:pPr>
-            <a:r>
-              <a:rPr lang="de-AT" b="0" i="0" u="none" strike="noStrike" dirty="0">
-                <a:solidFill>
-                  <a:srgbClr val="D1D5DB"/>
-                </a:solidFill>
-                <a:effectLst/>
-                <a:latin typeface="Söhne"/>
-              </a:rPr>
-              <a:t>Limited </a:t>
-            </a:r>
-            <a:r>
-              <a:rPr lang="de-AT" b="0" i="0" u="none" strike="noStrike" dirty="0" err="1">
-                <a:solidFill>
-                  <a:srgbClr val="D1D5DB"/>
-                </a:solidFill>
-                <a:effectLst/>
-                <a:latin typeface="Söhne"/>
-              </a:rPr>
-              <a:t>epochs</a:t>
-            </a:r>
-            <a:r>
-              <a:rPr lang="de-AT" b="0" i="0" u="none" strike="noStrike" dirty="0">
-                <a:solidFill>
-                  <a:srgbClr val="D1D5DB"/>
-                </a:solidFill>
-                <a:effectLst/>
-                <a:latin typeface="Söhne"/>
-              </a:rPr>
-              <a:t> (limited </a:t>
-            </a:r>
-            <a:r>
-              <a:rPr lang="de-AT" b="0" i="0" u="none" strike="noStrike" dirty="0" err="1">
-                <a:solidFill>
-                  <a:srgbClr val="D1D5DB"/>
-                </a:solidFill>
-                <a:effectLst/>
-                <a:latin typeface="Söhne"/>
-              </a:rPr>
-              <a:t>from</a:t>
-            </a:r>
-            <a:r>
-              <a:rPr lang="de-AT" b="0" i="0" u="none" strike="noStrike" dirty="0">
-                <a:solidFill>
-                  <a:srgbClr val="D1D5DB"/>
-                </a:solidFill>
-                <a:effectLst/>
-                <a:latin typeface="Söhne"/>
-              </a:rPr>
-              <a:t> 1000 </a:t>
-            </a:r>
-            <a:r>
-              <a:rPr lang="de-AT" b="0" i="0" u="none" strike="noStrike" dirty="0" err="1">
-                <a:solidFill>
-                  <a:srgbClr val="D1D5DB"/>
-                </a:solidFill>
-                <a:effectLst/>
-                <a:latin typeface="Söhne"/>
-              </a:rPr>
-              <a:t>to</a:t>
-            </a:r>
-            <a:r>
-              <a:rPr lang="de-AT" b="0" i="0" u="none" strike="noStrike" dirty="0">
-                <a:solidFill>
-                  <a:srgbClr val="D1D5DB"/>
-                </a:solidFill>
-                <a:effectLst/>
-                <a:latin typeface="Söhne"/>
-              </a:rPr>
-              <a:t> 100) due </a:t>
-            </a:r>
-            <a:r>
-              <a:rPr lang="de-AT" b="0" i="0" u="none" strike="noStrike" dirty="0" err="1">
-                <a:solidFill>
-                  <a:srgbClr val="D1D5DB"/>
-                </a:solidFill>
-                <a:effectLst/>
-                <a:latin typeface="Söhne"/>
-              </a:rPr>
-              <a:t>to</a:t>
-            </a:r>
-            <a:r>
-              <a:rPr lang="de-AT" b="0" i="0" u="none" strike="noStrike" dirty="0">
-                <a:solidFill>
-                  <a:srgbClr val="D1D5DB"/>
-                </a:solidFill>
-                <a:effectLst/>
-                <a:latin typeface="Söhne"/>
-              </a:rPr>
-              <a:t> </a:t>
-            </a:r>
-            <a:r>
-              <a:rPr lang="de-AT" b="0" i="0" u="none" strike="noStrike" dirty="0" err="1">
-                <a:solidFill>
-                  <a:srgbClr val="D1D5DB"/>
-                </a:solidFill>
-                <a:effectLst/>
-                <a:latin typeface="Söhne"/>
-              </a:rPr>
-              <a:t>training</a:t>
-            </a:r>
-            <a:r>
-              <a:rPr lang="de-AT" b="0" i="0" u="none" strike="noStrike" dirty="0">
-                <a:solidFill>
-                  <a:srgbClr val="D1D5DB"/>
-                </a:solidFill>
-                <a:effectLst/>
-                <a:latin typeface="Söhne"/>
-              </a:rPr>
-              <a:t> time and </a:t>
-            </a:r>
-            <a:r>
-              <a:rPr lang="de-AT" b="0" i="0" u="none" strike="noStrike" dirty="0" err="1">
-                <a:solidFill>
-                  <a:srgbClr val="D1D5DB"/>
-                </a:solidFill>
-                <a:effectLst/>
-                <a:latin typeface="Söhne"/>
-              </a:rPr>
-              <a:t>resource</a:t>
-            </a:r>
-            <a:r>
-              <a:rPr lang="de-AT" b="0" i="0" u="none" strike="noStrike" dirty="0">
-                <a:solidFill>
-                  <a:srgbClr val="D1D5DB"/>
-                </a:solidFill>
-                <a:effectLst/>
-                <a:latin typeface="Söhne"/>
-              </a:rPr>
-              <a:t> </a:t>
-            </a:r>
-            <a:r>
-              <a:rPr lang="de-AT" b="0" i="0" u="none" strike="noStrike" dirty="0" err="1">
-                <a:solidFill>
-                  <a:srgbClr val="D1D5DB"/>
-                </a:solidFill>
-                <a:effectLst/>
-                <a:latin typeface="Söhne"/>
-              </a:rPr>
-              <a:t>constraints</a:t>
-            </a:r>
-            <a:r>
-              <a:rPr lang="de-AT" b="0" i="0" u="none" strike="noStrike" dirty="0">
-                <a:solidFill>
-                  <a:srgbClr val="D1D5DB"/>
-                </a:solidFill>
-                <a:effectLst/>
-                <a:latin typeface="Söhne"/>
-              </a:rPr>
-              <a:t> </a:t>
-            </a:r>
-            <a:r>
-              <a:rPr lang="de-AT" b="0" i="0" u="none" strike="noStrike" dirty="0" err="1">
-                <a:solidFill>
-                  <a:srgbClr val="D1D5DB"/>
-                </a:solidFill>
-                <a:effectLst/>
-                <a:latin typeface="Söhne"/>
-              </a:rPr>
-              <a:t>may</a:t>
-            </a:r>
-            <a:r>
-              <a:rPr lang="de-AT" b="0" i="0" u="none" strike="noStrike" dirty="0">
-                <a:solidFill>
-                  <a:srgbClr val="D1D5DB"/>
-                </a:solidFill>
-                <a:effectLst/>
-                <a:latin typeface="Söhne"/>
-              </a:rPr>
-              <a:t> </a:t>
-            </a:r>
-            <a:r>
-              <a:rPr lang="de-AT" b="0" i="0" u="none" strike="noStrike" dirty="0" err="1">
-                <a:solidFill>
-                  <a:srgbClr val="D1D5DB"/>
-                </a:solidFill>
-                <a:effectLst/>
-                <a:latin typeface="Söhne"/>
-              </a:rPr>
-              <a:t>affect</a:t>
-            </a:r>
-            <a:r>
-              <a:rPr lang="de-AT" b="0" i="0" u="none" strike="noStrike" dirty="0">
-                <a:solidFill>
-                  <a:srgbClr val="D1D5DB"/>
-                </a:solidFill>
-                <a:effectLst/>
-                <a:latin typeface="Söhne"/>
-              </a:rPr>
-              <a:t> </a:t>
-            </a:r>
-            <a:r>
-              <a:rPr lang="de-AT" b="0" i="0" u="none" strike="noStrike" dirty="0" err="1">
-                <a:solidFill>
-                  <a:srgbClr val="D1D5DB"/>
-                </a:solidFill>
-                <a:effectLst/>
-                <a:latin typeface="Söhne"/>
-              </a:rPr>
-              <a:t>performance</a:t>
-            </a:r>
-            <a:r>
-              <a:rPr lang="de-AT" b="0" i="0" u="none" strike="noStrike" dirty="0">
-                <a:solidFill>
-                  <a:srgbClr val="D1D5DB"/>
-                </a:solidFill>
-                <a:effectLst/>
-                <a:latin typeface="Söhne"/>
-              </a:rPr>
-              <a:t>. </a:t>
-            </a:r>
-          </a:p>
-          <a:p>
-            <a:pPr>
-              <a:lnSpc>
-                <a:spcPct val="110000"/>
-              </a:lnSpc>
-            </a:pPr>
-            <a:r>
-              <a:rPr lang="de-AT" b="0" i="0" u="none" strike="noStrike" dirty="0" err="1">
-                <a:solidFill>
-                  <a:srgbClr val="D1D5DB"/>
-                </a:solidFill>
-                <a:effectLst/>
-                <a:latin typeface="Söhne"/>
-              </a:rPr>
-              <a:t>Optimizing</a:t>
-            </a:r>
-            <a:r>
-              <a:rPr lang="de-AT" b="0" i="0" u="none" strike="noStrike" dirty="0">
-                <a:solidFill>
-                  <a:srgbClr val="D1D5DB"/>
-                </a:solidFill>
-                <a:effectLst/>
-                <a:latin typeface="Söhne"/>
-              </a:rPr>
-              <a:t> </a:t>
-            </a:r>
-            <a:r>
-              <a:rPr lang="de-AT" b="0" i="0" u="none" strike="noStrike" dirty="0" err="1">
-                <a:solidFill>
-                  <a:srgbClr val="D1D5DB"/>
-                </a:solidFill>
-                <a:effectLst/>
-                <a:latin typeface="Söhne"/>
-              </a:rPr>
-              <a:t>training</a:t>
-            </a:r>
-            <a:r>
-              <a:rPr lang="de-AT" b="0" i="0" u="none" strike="noStrike" dirty="0">
-                <a:solidFill>
-                  <a:srgbClr val="D1D5DB"/>
-                </a:solidFill>
-                <a:effectLst/>
-                <a:latin typeface="Söhne"/>
-              </a:rPr>
-              <a:t> </a:t>
-            </a:r>
-            <a:r>
-              <a:rPr lang="de-AT" b="0" i="0" u="none" strike="noStrike" dirty="0" err="1">
-                <a:solidFill>
-                  <a:srgbClr val="D1D5DB"/>
-                </a:solidFill>
-                <a:effectLst/>
-                <a:latin typeface="Söhne"/>
-              </a:rPr>
-              <a:t>could</a:t>
-            </a:r>
-            <a:r>
-              <a:rPr lang="de-AT" b="0" i="0" u="none" strike="noStrike" dirty="0">
-                <a:solidFill>
-                  <a:srgbClr val="D1D5DB"/>
-                </a:solidFill>
-                <a:effectLst/>
-                <a:latin typeface="Söhne"/>
-              </a:rPr>
-              <a:t> </a:t>
-            </a:r>
-            <a:r>
-              <a:rPr lang="de-AT" b="0" i="0" u="none" strike="noStrike" dirty="0" err="1">
-                <a:solidFill>
-                  <a:srgbClr val="D1D5DB"/>
-                </a:solidFill>
-                <a:effectLst/>
-                <a:latin typeface="Söhne"/>
-              </a:rPr>
-              <a:t>improve</a:t>
-            </a:r>
-            <a:r>
-              <a:rPr lang="de-AT" b="0" i="0" u="none" strike="noStrike" dirty="0">
-                <a:solidFill>
-                  <a:srgbClr val="D1D5DB"/>
-                </a:solidFill>
-                <a:effectLst/>
-                <a:latin typeface="Söhne"/>
-              </a:rPr>
-              <a:t> </a:t>
-            </a:r>
-            <a:r>
-              <a:rPr lang="de-AT" b="0" i="0" u="none" strike="noStrike" dirty="0" err="1">
-                <a:solidFill>
-                  <a:srgbClr val="D1D5DB"/>
-                </a:solidFill>
-                <a:effectLst/>
-                <a:latin typeface="Söhne"/>
-              </a:rPr>
-              <a:t>detection</a:t>
-            </a:r>
-            <a:r>
-              <a:rPr lang="de-AT" b="0" i="0" u="none" strike="noStrike" dirty="0">
-                <a:solidFill>
-                  <a:srgbClr val="D1D5DB"/>
-                </a:solidFill>
-                <a:effectLst/>
-                <a:latin typeface="Söhne"/>
-              </a:rPr>
-              <a:t> in </a:t>
-            </a:r>
-            <a:r>
-              <a:rPr lang="de-AT" b="0" i="0" u="none" strike="noStrike" dirty="0" err="1">
-                <a:solidFill>
-                  <a:srgbClr val="D1D5DB"/>
-                </a:solidFill>
-                <a:effectLst/>
-                <a:latin typeface="Söhne"/>
-              </a:rPr>
-              <a:t>challenging</a:t>
-            </a:r>
-            <a:r>
-              <a:rPr lang="de-AT" b="0" i="0" u="none" strike="noStrike" dirty="0">
-                <a:solidFill>
-                  <a:srgbClr val="D1D5DB"/>
-                </a:solidFill>
-                <a:effectLst/>
-                <a:latin typeface="Söhne"/>
-              </a:rPr>
-              <a:t> </a:t>
-            </a:r>
-            <a:r>
-              <a:rPr lang="de-AT" b="0" i="0" u="none" strike="noStrike" dirty="0" err="1">
-                <a:solidFill>
-                  <a:srgbClr val="D1D5DB"/>
-                </a:solidFill>
-                <a:effectLst/>
-                <a:latin typeface="Söhne"/>
-              </a:rPr>
-              <a:t>cases</a:t>
-            </a:r>
-            <a:r>
-              <a:rPr lang="de-AT" b="0" i="0" u="none" strike="noStrike" dirty="0">
-                <a:solidFill>
-                  <a:srgbClr val="D1D5DB"/>
-                </a:solidFill>
-                <a:effectLst/>
-                <a:latin typeface="Söhne"/>
-              </a:rPr>
-              <a:t>.</a:t>
-            </a:r>
-            <a:endParaRPr lang="de-DE" dirty="0"/>
-          </a:p>
-          <a:p>
-            <a:endParaRPr lang="de-DE" dirty="0"/>
-          </a:p>
-        </p:txBody>
-      </p:sp>
-    </p:spTree>
-    <p:extLst>
-      <p:ext uri="{BB962C8B-B14F-4D97-AF65-F5344CB8AC3E}">
-        <p14:creationId xmlns:p14="http://schemas.microsoft.com/office/powerpoint/2010/main" val="3026436835"/>
       </p:ext>
     </p:extLst>
   </p:cSld>
@@ -9171,6 +8715,675 @@
       <p:bldP spid="2" grpId="0"/>
     </p:bldLst>
   </p:timing>
+</p:sld>
+</file>
+
+<file path=ppt/slides/slide20.xml><?xml version="1.0" encoding="utf-8"?>
+<p:sld xmlns:a="http://schemas.openxmlformats.org/drawingml/2006/main" xmlns:r="http://schemas.openxmlformats.org/officeDocument/2006/relationships" xmlns:p="http://schemas.openxmlformats.org/presentationml/2006/main">
+  <p:cSld>
+    <p:spTree>
+      <p:nvGrpSpPr>
+        <p:cNvPr id="1" name=""/>
+        <p:cNvGrpSpPr/>
+        <p:nvPr/>
+      </p:nvGrpSpPr>
+      <p:grpSpPr>
+        <a:xfrm>
+          <a:off x="0" y="0"/>
+          <a:ext cx="0" cy="0"/>
+          <a:chOff x="0" y="0"/>
+          <a:chExt cx="0" cy="0"/>
+        </a:xfrm>
+      </p:grpSpPr>
+      <p:sp>
+        <p:nvSpPr>
+          <p:cNvPr id="2" name="Titel 1">
+            <a:extLst>
+              <a:ext uri="{FF2B5EF4-FFF2-40B4-BE49-F238E27FC236}">
+                <a16:creationId xmlns:a16="http://schemas.microsoft.com/office/drawing/2014/main" id="{38CB1CBC-D7B9-75B5-CE88-82E3A32A7561}"/>
+              </a:ext>
+            </a:extLst>
+          </p:cNvPr>
+          <p:cNvSpPr>
+            <a:spLocks noGrp="1"/>
+          </p:cNvSpPr>
+          <p:nvPr>
+            <p:ph type="title"/>
+          </p:nvPr>
+        </p:nvSpPr>
+        <p:spPr/>
+        <p:txBody>
+          <a:bodyPr/>
+          <a:lstStyle/>
+          <a:p>
+            <a:r>
+              <a:rPr lang="de-DE" dirty="0" err="1"/>
+              <a:t>Conclusion</a:t>
+            </a:r>
+            <a:r>
+              <a:rPr lang="de-DE" dirty="0"/>
+              <a:t> </a:t>
+            </a:r>
+          </a:p>
+        </p:txBody>
+      </p:sp>
+      <p:sp>
+        <p:nvSpPr>
+          <p:cNvPr id="3" name="Inhaltsplatzhalter 2">
+            <a:extLst>
+              <a:ext uri="{FF2B5EF4-FFF2-40B4-BE49-F238E27FC236}">
+                <a16:creationId xmlns:a16="http://schemas.microsoft.com/office/drawing/2014/main" id="{C9B5F5CC-EC14-D5C3-36CC-F4B2BB3DF4C7}"/>
+              </a:ext>
+            </a:extLst>
+          </p:cNvPr>
+          <p:cNvSpPr>
+            <a:spLocks noGrp="1"/>
+          </p:cNvSpPr>
+          <p:nvPr>
+            <p:ph idx="1"/>
+          </p:nvPr>
+        </p:nvSpPr>
+        <p:spPr/>
+        <p:txBody>
+          <a:bodyPr/>
+          <a:lstStyle/>
+          <a:p>
+            <a:pPr>
+              <a:lnSpc>
+                <a:spcPct val="110000"/>
+              </a:lnSpc>
+            </a:pPr>
+            <a:r>
+              <a:rPr lang="de-AT" b="0" i="0" u="none" strike="noStrike" dirty="0">
+                <a:solidFill>
+                  <a:srgbClr val="D1D5DB"/>
+                </a:solidFill>
+                <a:effectLst/>
+                <a:latin typeface="Söhne"/>
+              </a:rPr>
+              <a:t>The </a:t>
+            </a:r>
+            <a:r>
+              <a:rPr lang="de-AT" b="0" i="0" u="none" strike="noStrike" dirty="0" err="1">
+                <a:solidFill>
+                  <a:srgbClr val="D1D5DB"/>
+                </a:solidFill>
+                <a:effectLst/>
+                <a:latin typeface="Söhne"/>
+              </a:rPr>
+              <a:t>model</a:t>
+            </a:r>
+            <a:r>
+              <a:rPr lang="de-AT" b="0" i="0" u="none" strike="noStrike" dirty="0">
+                <a:solidFill>
+                  <a:srgbClr val="D1D5DB"/>
+                </a:solidFill>
+                <a:effectLst/>
+                <a:latin typeface="Söhne"/>
+              </a:rPr>
+              <a:t> </a:t>
+            </a:r>
+            <a:r>
+              <a:rPr lang="de-AT" b="0" i="0" u="none" strike="noStrike" dirty="0" err="1">
+                <a:solidFill>
+                  <a:srgbClr val="D1D5DB"/>
+                </a:solidFill>
+                <a:effectLst/>
+                <a:latin typeface="Söhne"/>
+              </a:rPr>
+              <a:t>effectively</a:t>
+            </a:r>
+            <a:r>
+              <a:rPr lang="de-AT" b="0" i="0" u="none" strike="noStrike" dirty="0">
+                <a:solidFill>
+                  <a:srgbClr val="D1D5DB"/>
+                </a:solidFill>
+                <a:effectLst/>
+                <a:latin typeface="Söhne"/>
+              </a:rPr>
+              <a:t> </a:t>
+            </a:r>
+            <a:r>
+              <a:rPr lang="de-AT" b="0" i="0" u="none" strike="noStrike" dirty="0" err="1">
+                <a:solidFill>
+                  <a:srgbClr val="D1D5DB"/>
+                </a:solidFill>
+                <a:effectLst/>
+                <a:latin typeface="Söhne"/>
+              </a:rPr>
+              <a:t>identifies</a:t>
+            </a:r>
+            <a:r>
+              <a:rPr lang="de-AT" b="0" i="0" u="none" strike="noStrike" dirty="0">
+                <a:solidFill>
+                  <a:srgbClr val="D1D5DB"/>
+                </a:solidFill>
+                <a:effectLst/>
+                <a:latin typeface="Söhne"/>
+              </a:rPr>
+              <a:t> </a:t>
+            </a:r>
+            <a:r>
+              <a:rPr lang="de-AT" b="0" i="0" u="none" strike="noStrike" dirty="0" err="1">
+                <a:solidFill>
+                  <a:srgbClr val="D1D5DB"/>
+                </a:solidFill>
+                <a:effectLst/>
+                <a:latin typeface="Söhne"/>
+              </a:rPr>
+              <a:t>clear</a:t>
+            </a:r>
+            <a:r>
+              <a:rPr lang="de-AT" b="0" i="0" u="none" strike="noStrike" dirty="0">
+                <a:solidFill>
+                  <a:srgbClr val="D1D5DB"/>
+                </a:solidFill>
+                <a:effectLst/>
+                <a:latin typeface="Söhne"/>
+              </a:rPr>
+              <a:t> </a:t>
+            </a:r>
+            <a:r>
+              <a:rPr lang="de-AT" b="0" i="0" u="none" strike="noStrike" dirty="0" err="1">
+                <a:solidFill>
+                  <a:srgbClr val="D1D5DB"/>
+                </a:solidFill>
+                <a:effectLst/>
+                <a:latin typeface="Söhne"/>
+              </a:rPr>
+              <a:t>tumors</a:t>
+            </a:r>
+            <a:r>
+              <a:rPr lang="de-AT" b="0" i="0" u="none" strike="noStrike" dirty="0">
+                <a:solidFill>
+                  <a:srgbClr val="D1D5DB"/>
+                </a:solidFill>
+                <a:effectLst/>
+                <a:latin typeface="Söhne"/>
+              </a:rPr>
+              <a:t> but </a:t>
+            </a:r>
+            <a:r>
+              <a:rPr lang="de-AT" b="0" i="0" u="none" strike="noStrike" dirty="0" err="1">
+                <a:solidFill>
+                  <a:srgbClr val="D1D5DB"/>
+                </a:solidFill>
+                <a:effectLst/>
+                <a:latin typeface="Söhne"/>
+              </a:rPr>
+              <a:t>struggles</a:t>
+            </a:r>
+            <a:r>
+              <a:rPr lang="de-AT" b="0" i="0" u="none" strike="noStrike" dirty="0">
+                <a:solidFill>
+                  <a:srgbClr val="D1D5DB"/>
+                </a:solidFill>
+                <a:effectLst/>
+                <a:latin typeface="Söhne"/>
+              </a:rPr>
+              <a:t> </a:t>
+            </a:r>
+            <a:r>
+              <a:rPr lang="de-AT" b="0" i="0" u="none" strike="noStrike" dirty="0" err="1">
+                <a:solidFill>
+                  <a:srgbClr val="D1D5DB"/>
+                </a:solidFill>
+                <a:effectLst/>
+                <a:latin typeface="Söhne"/>
+              </a:rPr>
+              <a:t>with</a:t>
+            </a:r>
+            <a:r>
+              <a:rPr lang="de-AT" b="0" i="0" u="none" strike="noStrike" dirty="0">
+                <a:solidFill>
+                  <a:srgbClr val="D1D5DB"/>
+                </a:solidFill>
+                <a:effectLst/>
+                <a:latin typeface="Söhne"/>
+              </a:rPr>
+              <a:t> </a:t>
+            </a:r>
+            <a:r>
+              <a:rPr lang="de-AT" b="0" i="0" u="none" strike="noStrike" dirty="0" err="1">
+                <a:solidFill>
+                  <a:srgbClr val="D1D5DB"/>
+                </a:solidFill>
+                <a:effectLst/>
+                <a:latin typeface="Söhne"/>
+              </a:rPr>
+              <a:t>less</a:t>
+            </a:r>
+            <a:r>
+              <a:rPr lang="de-AT" b="0" i="0" u="none" strike="noStrike" dirty="0">
+                <a:solidFill>
+                  <a:srgbClr val="D1D5DB"/>
+                </a:solidFill>
+                <a:effectLst/>
+                <a:latin typeface="Söhne"/>
+              </a:rPr>
+              <a:t> </a:t>
+            </a:r>
+            <a:r>
+              <a:rPr lang="de-AT" b="0" i="0" u="none" strike="noStrike" dirty="0" err="1">
+                <a:solidFill>
+                  <a:srgbClr val="D1D5DB"/>
+                </a:solidFill>
+                <a:effectLst/>
+                <a:latin typeface="Söhne"/>
+              </a:rPr>
+              <a:t>distinct</a:t>
+            </a:r>
+            <a:r>
+              <a:rPr lang="de-AT" b="0" i="0" u="none" strike="noStrike" dirty="0">
+                <a:solidFill>
+                  <a:srgbClr val="D1D5DB"/>
+                </a:solidFill>
+                <a:effectLst/>
+                <a:latin typeface="Söhne"/>
+              </a:rPr>
+              <a:t> </a:t>
+            </a:r>
+            <a:r>
+              <a:rPr lang="de-AT" b="0" i="0" u="none" strike="noStrike" dirty="0" err="1">
+                <a:solidFill>
+                  <a:srgbClr val="D1D5DB"/>
+                </a:solidFill>
+                <a:effectLst/>
+                <a:latin typeface="Söhne"/>
+              </a:rPr>
+              <a:t>ones</a:t>
+            </a:r>
+            <a:r>
+              <a:rPr lang="de-AT" b="0" i="0" u="none" strike="noStrike" dirty="0">
+                <a:solidFill>
+                  <a:srgbClr val="D1D5DB"/>
+                </a:solidFill>
+                <a:effectLst/>
+                <a:latin typeface="Söhne"/>
+              </a:rPr>
+              <a:t>. </a:t>
+            </a:r>
+          </a:p>
+          <a:p>
+            <a:pPr>
+              <a:lnSpc>
+                <a:spcPct val="110000"/>
+              </a:lnSpc>
+            </a:pPr>
+            <a:r>
+              <a:rPr lang="de-AT" b="0" i="0" u="none" strike="noStrike" dirty="0">
+                <a:solidFill>
+                  <a:srgbClr val="D1D5DB"/>
+                </a:solidFill>
+                <a:effectLst/>
+                <a:latin typeface="Söhne"/>
+              </a:rPr>
+              <a:t>Limited </a:t>
+            </a:r>
+            <a:r>
+              <a:rPr lang="de-AT" b="0" i="0" u="none" strike="noStrike" dirty="0" err="1">
+                <a:solidFill>
+                  <a:srgbClr val="D1D5DB"/>
+                </a:solidFill>
+                <a:effectLst/>
+                <a:latin typeface="Söhne"/>
+              </a:rPr>
+              <a:t>epochs</a:t>
+            </a:r>
+            <a:r>
+              <a:rPr lang="de-AT" b="0" i="0" u="none" strike="noStrike" dirty="0">
+                <a:solidFill>
+                  <a:srgbClr val="D1D5DB"/>
+                </a:solidFill>
+                <a:effectLst/>
+                <a:latin typeface="Söhne"/>
+              </a:rPr>
+              <a:t> (limited </a:t>
+            </a:r>
+            <a:r>
+              <a:rPr lang="de-AT" b="0" i="0" u="none" strike="noStrike" dirty="0" err="1">
+                <a:solidFill>
+                  <a:srgbClr val="D1D5DB"/>
+                </a:solidFill>
+                <a:effectLst/>
+                <a:latin typeface="Söhne"/>
+              </a:rPr>
+              <a:t>from</a:t>
+            </a:r>
+            <a:r>
+              <a:rPr lang="de-AT" b="0" i="0" u="none" strike="noStrike" dirty="0">
+                <a:solidFill>
+                  <a:srgbClr val="D1D5DB"/>
+                </a:solidFill>
+                <a:effectLst/>
+                <a:latin typeface="Söhne"/>
+              </a:rPr>
+              <a:t> 1000 </a:t>
+            </a:r>
+            <a:r>
+              <a:rPr lang="de-AT" b="0" i="0" u="none" strike="noStrike" dirty="0" err="1">
+                <a:solidFill>
+                  <a:srgbClr val="D1D5DB"/>
+                </a:solidFill>
+                <a:effectLst/>
+                <a:latin typeface="Söhne"/>
+              </a:rPr>
+              <a:t>to</a:t>
+            </a:r>
+            <a:r>
+              <a:rPr lang="de-AT" b="0" i="0" u="none" strike="noStrike" dirty="0">
+                <a:solidFill>
+                  <a:srgbClr val="D1D5DB"/>
+                </a:solidFill>
+                <a:effectLst/>
+                <a:latin typeface="Söhne"/>
+              </a:rPr>
+              <a:t> 100) due </a:t>
+            </a:r>
+            <a:r>
+              <a:rPr lang="de-AT" b="0" i="0" u="none" strike="noStrike" dirty="0" err="1">
+                <a:solidFill>
+                  <a:srgbClr val="D1D5DB"/>
+                </a:solidFill>
+                <a:effectLst/>
+                <a:latin typeface="Söhne"/>
+              </a:rPr>
+              <a:t>to</a:t>
+            </a:r>
+            <a:r>
+              <a:rPr lang="de-AT" b="0" i="0" u="none" strike="noStrike" dirty="0">
+                <a:solidFill>
+                  <a:srgbClr val="D1D5DB"/>
+                </a:solidFill>
+                <a:effectLst/>
+                <a:latin typeface="Söhne"/>
+              </a:rPr>
+              <a:t> </a:t>
+            </a:r>
+            <a:r>
+              <a:rPr lang="de-AT" b="0" i="0" u="none" strike="noStrike" dirty="0" err="1">
+                <a:solidFill>
+                  <a:srgbClr val="D1D5DB"/>
+                </a:solidFill>
+                <a:effectLst/>
+                <a:latin typeface="Söhne"/>
+              </a:rPr>
+              <a:t>training</a:t>
+            </a:r>
+            <a:r>
+              <a:rPr lang="de-AT" b="0" i="0" u="none" strike="noStrike" dirty="0">
+                <a:solidFill>
+                  <a:srgbClr val="D1D5DB"/>
+                </a:solidFill>
+                <a:effectLst/>
+                <a:latin typeface="Söhne"/>
+              </a:rPr>
+              <a:t> time and </a:t>
+            </a:r>
+            <a:r>
+              <a:rPr lang="de-AT" b="0" i="0" u="none" strike="noStrike" dirty="0" err="1">
+                <a:solidFill>
+                  <a:srgbClr val="D1D5DB"/>
+                </a:solidFill>
+                <a:effectLst/>
+                <a:latin typeface="Söhne"/>
+              </a:rPr>
+              <a:t>resource</a:t>
+            </a:r>
+            <a:r>
+              <a:rPr lang="de-AT" b="0" i="0" u="none" strike="noStrike" dirty="0">
+                <a:solidFill>
+                  <a:srgbClr val="D1D5DB"/>
+                </a:solidFill>
+                <a:effectLst/>
+                <a:latin typeface="Söhne"/>
+              </a:rPr>
+              <a:t> </a:t>
+            </a:r>
+            <a:r>
+              <a:rPr lang="de-AT" b="0" i="0" u="none" strike="noStrike" dirty="0" err="1">
+                <a:solidFill>
+                  <a:srgbClr val="D1D5DB"/>
+                </a:solidFill>
+                <a:effectLst/>
+                <a:latin typeface="Söhne"/>
+              </a:rPr>
+              <a:t>constraints</a:t>
+            </a:r>
+            <a:r>
+              <a:rPr lang="de-AT" b="0" i="0" u="none" strike="noStrike" dirty="0">
+                <a:solidFill>
+                  <a:srgbClr val="D1D5DB"/>
+                </a:solidFill>
+                <a:effectLst/>
+                <a:latin typeface="Söhne"/>
+              </a:rPr>
+              <a:t> </a:t>
+            </a:r>
+            <a:r>
+              <a:rPr lang="de-AT" b="0" i="0" u="none" strike="noStrike" dirty="0" err="1">
+                <a:solidFill>
+                  <a:srgbClr val="D1D5DB"/>
+                </a:solidFill>
+                <a:effectLst/>
+                <a:latin typeface="Söhne"/>
+              </a:rPr>
+              <a:t>may</a:t>
+            </a:r>
+            <a:r>
+              <a:rPr lang="de-AT" b="0" i="0" u="none" strike="noStrike" dirty="0">
+                <a:solidFill>
+                  <a:srgbClr val="D1D5DB"/>
+                </a:solidFill>
+                <a:effectLst/>
+                <a:latin typeface="Söhne"/>
+              </a:rPr>
+              <a:t> </a:t>
+            </a:r>
+            <a:r>
+              <a:rPr lang="de-AT" b="0" i="0" u="none" strike="noStrike" dirty="0" err="1">
+                <a:solidFill>
+                  <a:srgbClr val="D1D5DB"/>
+                </a:solidFill>
+                <a:effectLst/>
+                <a:latin typeface="Söhne"/>
+              </a:rPr>
+              <a:t>affect</a:t>
+            </a:r>
+            <a:r>
+              <a:rPr lang="de-AT" b="0" i="0" u="none" strike="noStrike" dirty="0">
+                <a:solidFill>
+                  <a:srgbClr val="D1D5DB"/>
+                </a:solidFill>
+                <a:effectLst/>
+                <a:latin typeface="Söhne"/>
+              </a:rPr>
+              <a:t> </a:t>
+            </a:r>
+            <a:r>
+              <a:rPr lang="de-AT" b="0" i="0" u="none" strike="noStrike" dirty="0" err="1">
+                <a:solidFill>
+                  <a:srgbClr val="D1D5DB"/>
+                </a:solidFill>
+                <a:effectLst/>
+                <a:latin typeface="Söhne"/>
+              </a:rPr>
+              <a:t>performance</a:t>
+            </a:r>
+            <a:r>
+              <a:rPr lang="de-AT" b="0" i="0" u="none" strike="noStrike" dirty="0">
+                <a:solidFill>
+                  <a:srgbClr val="D1D5DB"/>
+                </a:solidFill>
+                <a:effectLst/>
+                <a:latin typeface="Söhne"/>
+              </a:rPr>
+              <a:t>. </a:t>
+            </a:r>
+          </a:p>
+          <a:p>
+            <a:pPr>
+              <a:lnSpc>
+                <a:spcPct val="110000"/>
+              </a:lnSpc>
+            </a:pPr>
+            <a:r>
+              <a:rPr lang="de-AT" b="0" i="0" u="none" strike="noStrike" dirty="0" err="1">
+                <a:solidFill>
+                  <a:srgbClr val="D1D5DB"/>
+                </a:solidFill>
+                <a:effectLst/>
+                <a:latin typeface="Söhne"/>
+              </a:rPr>
+              <a:t>Optimizing</a:t>
+            </a:r>
+            <a:r>
+              <a:rPr lang="de-AT" b="0" i="0" u="none" strike="noStrike" dirty="0">
+                <a:solidFill>
+                  <a:srgbClr val="D1D5DB"/>
+                </a:solidFill>
+                <a:effectLst/>
+                <a:latin typeface="Söhne"/>
+              </a:rPr>
+              <a:t> </a:t>
+            </a:r>
+            <a:r>
+              <a:rPr lang="de-AT" b="0" i="0" u="none" strike="noStrike" dirty="0" err="1">
+                <a:solidFill>
+                  <a:srgbClr val="D1D5DB"/>
+                </a:solidFill>
+                <a:effectLst/>
+                <a:latin typeface="Söhne"/>
+              </a:rPr>
+              <a:t>training</a:t>
+            </a:r>
+            <a:r>
+              <a:rPr lang="de-AT" b="0" i="0" u="none" strike="noStrike" dirty="0">
+                <a:solidFill>
+                  <a:srgbClr val="D1D5DB"/>
+                </a:solidFill>
+                <a:effectLst/>
+                <a:latin typeface="Söhne"/>
+              </a:rPr>
+              <a:t> </a:t>
+            </a:r>
+            <a:r>
+              <a:rPr lang="de-AT" b="0" i="0" u="none" strike="noStrike" dirty="0" err="1">
+                <a:solidFill>
+                  <a:srgbClr val="D1D5DB"/>
+                </a:solidFill>
+                <a:effectLst/>
+                <a:latin typeface="Söhne"/>
+              </a:rPr>
+              <a:t>could</a:t>
+            </a:r>
+            <a:r>
+              <a:rPr lang="de-AT" b="0" i="0" u="none" strike="noStrike" dirty="0">
+                <a:solidFill>
+                  <a:srgbClr val="D1D5DB"/>
+                </a:solidFill>
+                <a:effectLst/>
+                <a:latin typeface="Söhne"/>
+              </a:rPr>
+              <a:t> </a:t>
+            </a:r>
+            <a:r>
+              <a:rPr lang="de-AT" b="0" i="0" u="none" strike="noStrike" dirty="0" err="1">
+                <a:solidFill>
+                  <a:srgbClr val="D1D5DB"/>
+                </a:solidFill>
+                <a:effectLst/>
+                <a:latin typeface="Söhne"/>
+              </a:rPr>
+              <a:t>improve</a:t>
+            </a:r>
+            <a:r>
+              <a:rPr lang="de-AT" b="0" i="0" u="none" strike="noStrike" dirty="0">
+                <a:solidFill>
+                  <a:srgbClr val="D1D5DB"/>
+                </a:solidFill>
+                <a:effectLst/>
+                <a:latin typeface="Söhne"/>
+              </a:rPr>
+              <a:t> </a:t>
+            </a:r>
+            <a:r>
+              <a:rPr lang="de-AT" b="0" i="0" u="none" strike="noStrike" dirty="0" err="1">
+                <a:solidFill>
+                  <a:srgbClr val="D1D5DB"/>
+                </a:solidFill>
+                <a:effectLst/>
+                <a:latin typeface="Söhne"/>
+              </a:rPr>
+              <a:t>detection</a:t>
+            </a:r>
+            <a:r>
+              <a:rPr lang="de-AT" b="0" i="0" u="none" strike="noStrike" dirty="0">
+                <a:solidFill>
+                  <a:srgbClr val="D1D5DB"/>
+                </a:solidFill>
+                <a:effectLst/>
+                <a:latin typeface="Söhne"/>
+              </a:rPr>
+              <a:t> in </a:t>
+            </a:r>
+            <a:r>
+              <a:rPr lang="de-AT" b="0" i="0" u="none" strike="noStrike" dirty="0" err="1">
+                <a:solidFill>
+                  <a:srgbClr val="D1D5DB"/>
+                </a:solidFill>
+                <a:effectLst/>
+                <a:latin typeface="Söhne"/>
+              </a:rPr>
+              <a:t>challenging</a:t>
+            </a:r>
+            <a:r>
+              <a:rPr lang="de-AT" b="0" i="0" u="none" strike="noStrike" dirty="0">
+                <a:solidFill>
+                  <a:srgbClr val="D1D5DB"/>
+                </a:solidFill>
+                <a:effectLst/>
+                <a:latin typeface="Söhne"/>
+              </a:rPr>
+              <a:t> </a:t>
+            </a:r>
+            <a:r>
+              <a:rPr lang="de-AT" b="0" i="0" u="none" strike="noStrike" dirty="0" err="1">
+                <a:solidFill>
+                  <a:srgbClr val="D1D5DB"/>
+                </a:solidFill>
+                <a:effectLst/>
+                <a:latin typeface="Söhne"/>
+              </a:rPr>
+              <a:t>cases</a:t>
+            </a:r>
+            <a:r>
+              <a:rPr lang="de-AT" b="0" i="0" u="none" strike="noStrike" dirty="0">
+                <a:solidFill>
+                  <a:srgbClr val="D1D5DB"/>
+                </a:solidFill>
+                <a:effectLst/>
+                <a:latin typeface="Söhne"/>
+              </a:rPr>
+              <a:t>.</a:t>
+            </a:r>
+            <a:endParaRPr lang="de-DE" dirty="0"/>
+          </a:p>
+          <a:p>
+            <a:endParaRPr lang="de-DE" dirty="0"/>
+          </a:p>
+        </p:txBody>
+      </p:sp>
+    </p:spTree>
+    <p:extLst>
+      <p:ext uri="{BB962C8B-B14F-4D97-AF65-F5344CB8AC3E}">
+        <p14:creationId xmlns:p14="http://schemas.microsoft.com/office/powerpoint/2010/main" val="3026436835"/>
+      </p:ext>
+    </p:extLst>
+  </p:cSld>
+  <p:clrMapOvr>
+    <a:masterClrMapping/>
+  </p:clrMapOvr>
 </p:sld>
 </file>
 

</xml_diff>